<commit_message>
Models: add Kubeflow↔SageMaker systematic view + platform fine-tune lab
- README: "Systematic view · Kubeflow - Sagemaker" — faithful Kubeflow
  architecture (verbatim component names) + Kubeflow/SageMaker mapping table
- labs/kubeflow-sagemaker/: re-express Lab 2's QLoRA order-parser fine-tune
  in platform language — shared train.py entrypoint, one notebook submitting
  it via Kubeflow Trainer (Track A) and SageMaker (Track B), + README
- labs/README: pointer to the new "beyond Kaggle" reference lab
- slides.md/pdf/pptx: synced capstone slide

Co-Authored-By: Claude Opus 4.8 (1M context) <noreply@anthropic.com>
</commit_message>
<xml_diff>
--- a/02-models/slides.pptx
+++ b/02-models/slides.pptx
@@ -19,9 +19,10 @@
     <p:sldId id="267" r:id="rId13"/>
     <p:sldId id="268" r:id="rId14"/>
     <p:sldId id="269" r:id="rId15"/>
+    <p:sldId id="270" r:id="rId16"/>
   </p:sldIdLst>
   <p:notesMasterIdLst>
-    <p:notesMasterId r:id="rId16"/>
+    <p:notesMasterId r:id="rId17"/>
   </p:notesMasterIdLst>
   <p:sldSz cx="12192000" cy="6858000"/>
   <p:notesSz cx="6858000" cy="12192000"/>
@@ -874,6 +875,99 @@
           <a:p>
             <a:r>
               <a:rPr lang="en-US" dirty="0"/>
+              <a:t>The capstone: our seven phases aren't ad-hoc — they're the lifecycle every
+platform implements. Kubeflow = open, on your Kubernetes; SageMaker = AWS-managed,
+same stages. Keep Kubeflow's real component names. The labs/kubeflow-sagemaker/
+lab re-expresses the Kaggle fine-tune in both: Kubeflow Trainer takes a function,
+SageMaker takes a script, both run the identical train.py. The eval gate (Lab 3)
+becomes a Pipelines step that blocks a regressed deploy.</a:t>
+            </a:r>
+            <a:endParaRPr lang="en-US" dirty="0"/>
+          </a:p>
+        </p:txBody>
+      </p:sp>
+      <p:sp>
+        <p:nvSpPr>
+          <p:cNvPr id="4" name="Slide Number Placeholder 3"/>
+          <p:cNvSpPr>
+            <a:spLocks noGrp="1"/>
+          </p:cNvSpPr>
+          <p:nvPr>
+            <p:ph type="sldNum" sz="quarter" idx="10"/>
+          </p:nvPr>
+        </p:nvSpPr>
+        <p:spPr/>
+        <p:txBody>
+          <a:bodyPr/>
+          <a:lstStyle/>
+          <a:p>
+            <a:fld id="{F7021451-1387-4CA6-816F-3879F97B5CBC}" type="slidenum">
+              <a:rPr lang="en-US"/>
+              <a:t>13</a:t>
+            </a:fld>
+            <a:endParaRPr lang="en-US"/>
+          </a:p>
+        </p:txBody>
+      </p:sp>
+    </p:spTree>
+    <p:extLst>
+      <p:ext uri="{BB962C8B-B14F-4D97-AF65-F5344CB8AC3E}">
+        <p14:creationId xmlns:p14="http://schemas.microsoft.com/office/powerpoint/2010/main" val="1024086991"/>
+      </p:ext>
+    </p:extLst>
+  </p:cSld>
+  <p:clrMapOvr>
+    <a:masterClrMapping/>
+  </p:clrMapOvr>
+</p:notes>
+</file>
+
+<file path=ppt/notesSlides/notesSlide14.xml><?xml version="1.0" encoding="utf-8"?>
+<p:notes xmlns:a="http://schemas.openxmlformats.org/drawingml/2006/main" xmlns:r="http://schemas.openxmlformats.org/officeDocument/2006/relationships" xmlns:p="http://schemas.openxmlformats.org/presentationml/2006/main">
+  <p:cSld>
+    <p:spTree>
+      <p:nvGrpSpPr>
+        <p:cNvPr id="1" name=""/>
+        <p:cNvGrpSpPr/>
+        <p:nvPr/>
+      </p:nvGrpSpPr>
+      <p:grpSpPr>
+        <a:xfrm>
+          <a:off x="0" y="0"/>
+          <a:ext cx="0" cy="0"/>
+          <a:chOff x="0" y="0"/>
+          <a:chExt cx="0" cy="0"/>
+        </a:xfrm>
+      </p:grpSpPr>
+      <p:sp>
+        <p:nvSpPr>
+          <p:cNvPr id="2" name="Slide Image Placeholder 1"/>
+          <p:cNvSpPr>
+            <a:spLocks noGrp="1" noRot="1" noChangeAspect="1"/>
+          </p:cNvSpPr>
+          <p:nvPr>
+            <p:ph type="sldImg"/>
+          </p:nvPr>
+        </p:nvSpPr>
+        <p:spPr/>
+      </p:sp>
+      <p:sp>
+        <p:nvSpPr>
+          <p:cNvPr id="3" name="Notes Placeholder 2"/>
+          <p:cNvSpPr>
+            <a:spLocks noGrp="1"/>
+          </p:cNvSpPr>
+          <p:nvPr>
+            <p:ph type="body" idx="1"/>
+          </p:nvPr>
+        </p:nvSpPr>
+        <p:spPr/>
+        <p:txBody>
+          <a:bodyPr/>
+          <a:lstStyle/>
+          <a:p>
+            <a:r>
+              <a:rPr lang="en-US" dirty="0"/>
               <a:t>The mirror of the SLM argument. Don't sell it as prediction — the book predates
 LLMs. The two theses are the keepers: smart isn't safe; wrong-goal competence is
 the danger.</a:t>
@@ -899,7 +993,7 @@
           <a:p>
             <a:fld id="{F7021451-1387-4CA6-816F-3879F97B5CBC}" type="slidenum">
               <a:rPr lang="en-US"/>
-              <a:t>13</a:t>
+              <a:t>14</a:t>
             </a:fld>
             <a:endParaRPr lang="en-US"/>
           </a:p>
@@ -918,7 +1012,7 @@
 </p:notes>
 </file>
 
-<file path=ppt/notesSlides/notesSlide14.xml><?xml version="1.0" encoding="utf-8"?>
+<file path=ppt/notesSlides/notesSlide15.xml><?xml version="1.0" encoding="utf-8"?>
 <p:notes xmlns:a="http://schemas.openxmlformats.org/drawingml/2006/main" xmlns:r="http://schemas.openxmlformats.org/officeDocument/2006/relationships" xmlns:p="http://schemas.openxmlformats.org/presentationml/2006/main">
   <p:cSld>
     <p:spTree>
@@ -988,7 +1082,7 @@
           <a:p>
             <a:fld id="{F7021451-1387-4CA6-816F-3879F97B5CBC}" type="slidenum">
               <a:rPr lang="en-US"/>
-              <a:t>14</a:t>
+              <a:t>15</a:t>
             </a:fld>
             <a:endParaRPr lang="en-US"/>
           </a:p>
@@ -2226,6 +2320,45 @@
 <file path=ppt/slides/slide14.xml><?xml version="1.0" encoding="utf-8"?>
 <p:sld xmlns:a="http://schemas.openxmlformats.org/drawingml/2006/main" xmlns:r="http://schemas.openxmlformats.org/officeDocument/2006/relationships" xmlns:p="http://schemas.openxmlformats.org/presentationml/2006/main">
   <p:cSld name="Slide 14">
+    <p:bg>
+      <p:bgPr>
+        <a:blipFill dpi="0" rotWithShape="1">
+          <a:blip r:embed="rId1">
+            <a:lum/>
+          </a:blip>
+          <a:srcRect/>
+          <a:stretch>
+            <a:fillRect/>
+          </a:stretch>
+        </a:blipFill>
+        <a:effectLst/>
+      </p:bgPr>
+    </p:bg>
+    <p:spTree>
+      <p:nvGrpSpPr>
+        <p:cNvPr id="1" name=""/>
+        <p:cNvGrpSpPr/>
+        <p:nvPr/>
+      </p:nvGrpSpPr>
+      <p:grpSpPr>
+        <a:xfrm>
+          <a:off x="0" y="0"/>
+          <a:ext cx="0" cy="0"/>
+          <a:chOff x="0" y="0"/>
+          <a:chExt cx="0" cy="0"/>
+        </a:xfrm>
+      </p:grpSpPr>
+    </p:spTree>
+  </p:cSld>
+  <p:clrMapOvr>
+    <a:masterClrMapping/>
+  </p:clrMapOvr>
+</p:sld>
+</file>
+
+<file path=ppt/slides/slide15.xml><?xml version="1.0" encoding="utf-8"?>
+<p:sld xmlns:a="http://schemas.openxmlformats.org/drawingml/2006/main" xmlns:r="http://schemas.openxmlformats.org/officeDocument/2006/relationships" xmlns:p="http://schemas.openxmlformats.org/presentationml/2006/main">
+  <p:cSld name="Slide 15">
     <p:bg>
       <p:bgPr>
         <a:blipFill dpi="0" rotWithShape="1">

</xml_diff>

<commit_message>
Models deck: add systematic-view diagram, drop superintelligence aside
- systematic-view.svg: visual Kubeflow↔SageMaker architecture (layered
  interface/orchestrate/lifecycle/metadata/infra, KF vs SageMaker per stage)
- slides.md: systematic-view slide now shows the diagram (was a table);
  remove the "Aside · superintelligence" slide
- rebuild slides.pdf + slides.pptx

Co-Authored-By: Claude Opus 4.8 (1M context) <noreply@anthropic.com>
</commit_message>
<xml_diff>
--- a/02-models/slides.pptx
+++ b/02-models/slides.pptx
@@ -19,10 +19,9 @@
     <p:sldId id="267" r:id="rId13"/>
     <p:sldId id="268" r:id="rId14"/>
     <p:sldId id="269" r:id="rId15"/>
-    <p:sldId id="270" r:id="rId16"/>
   </p:sldIdLst>
   <p:notesMasterIdLst>
-    <p:notesMasterId r:id="rId17"/>
+    <p:notesMasterId r:id="rId16"/>
   </p:notesMasterIdLst>
   <p:sldSz cx="12192000" cy="6858000"/>
   <p:notesSz cx="6858000" cy="12192000"/>
@@ -968,96 +967,6 @@
           <a:p>
             <a:r>
               <a:rPr lang="en-US" dirty="0"/>
-              <a:t>The mirror of the SLM argument. Don't sell it as prediction — the book predates
-LLMs. The two theses are the keepers: smart isn't safe; wrong-goal competence is
-the danger.</a:t>
-            </a:r>
-            <a:endParaRPr lang="en-US" dirty="0"/>
-          </a:p>
-        </p:txBody>
-      </p:sp>
-      <p:sp>
-        <p:nvSpPr>
-          <p:cNvPr id="4" name="Slide Number Placeholder 3"/>
-          <p:cNvSpPr>
-            <a:spLocks noGrp="1"/>
-          </p:cNvSpPr>
-          <p:nvPr>
-            <p:ph type="sldNum" sz="quarter" idx="10"/>
-          </p:nvPr>
-        </p:nvSpPr>
-        <p:spPr/>
-        <p:txBody>
-          <a:bodyPr/>
-          <a:lstStyle/>
-          <a:p>
-            <a:fld id="{F7021451-1387-4CA6-816F-3879F97B5CBC}" type="slidenum">
-              <a:rPr lang="en-US"/>
-              <a:t>14</a:t>
-            </a:fld>
-            <a:endParaRPr lang="en-US"/>
-          </a:p>
-        </p:txBody>
-      </p:sp>
-    </p:spTree>
-    <p:extLst>
-      <p:ext uri="{BB962C8B-B14F-4D97-AF65-F5344CB8AC3E}">
-        <p14:creationId xmlns:p14="http://schemas.microsoft.com/office/powerpoint/2010/main" val="1024086991"/>
-      </p:ext>
-    </p:extLst>
-  </p:cSld>
-  <p:clrMapOvr>
-    <a:masterClrMapping/>
-  </p:clrMapOvr>
-</p:notes>
-</file>
-
-<file path=ppt/notesSlides/notesSlide15.xml><?xml version="1.0" encoding="utf-8"?>
-<p:notes xmlns:a="http://schemas.openxmlformats.org/drawingml/2006/main" xmlns:r="http://schemas.openxmlformats.org/officeDocument/2006/relationships" xmlns:p="http://schemas.openxmlformats.org/presentationml/2006/main">
-  <p:cSld>
-    <p:spTree>
-      <p:nvGrpSpPr>
-        <p:cNvPr id="1" name=""/>
-        <p:cNvGrpSpPr/>
-        <p:nvPr/>
-      </p:nvGrpSpPr>
-      <p:grpSpPr>
-        <a:xfrm>
-          <a:off x="0" y="0"/>
-          <a:ext cx="0" cy="0"/>
-          <a:chOff x="0" y="0"/>
-          <a:chExt cx="0" cy="0"/>
-        </a:xfrm>
-      </p:grpSpPr>
-      <p:sp>
-        <p:nvSpPr>
-          <p:cNvPr id="2" name="Slide Image Placeholder 1"/>
-          <p:cNvSpPr>
-            <a:spLocks noGrp="1" noRot="1" noChangeAspect="1"/>
-          </p:cNvSpPr>
-          <p:nvPr>
-            <p:ph type="sldImg"/>
-          </p:nvPr>
-        </p:nvSpPr>
-        <p:spPr/>
-      </p:sp>
-      <p:sp>
-        <p:nvSpPr>
-          <p:cNvPr id="3" name="Notes Placeholder 2"/>
-          <p:cNvSpPr>
-            <a:spLocks noGrp="1"/>
-          </p:cNvSpPr>
-          <p:nvPr>
-            <p:ph type="body" idx="1"/>
-          </p:nvPr>
-        </p:nvSpPr>
-        <p:spPr/>
-        <p:txBody>
-          <a:bodyPr/>
-          <a:lstStyle/>
-          <a:p>
-            <a:r>
-              <a:rPr lang="en-US" dirty="0"/>
               <a:t>The part builders use. Students already build oracles and genies. Bostrom's
 ranking (oracle/tool safe, sovereign risky) is a real design choice in layer 4.</a:t>
             </a:r>
@@ -1082,7 +991,7 @@
           <a:p>
             <a:fld id="{F7021451-1387-4CA6-816F-3879F97B5CBC}" type="slidenum">
               <a:rPr lang="en-US"/>
-              <a:t>15</a:t>
+              <a:t>14</a:t>
             </a:fld>
             <a:endParaRPr lang="en-US"/>
           </a:p>
@@ -2320,45 +2229,6 @@
 <file path=ppt/slides/slide14.xml><?xml version="1.0" encoding="utf-8"?>
 <p:sld xmlns:a="http://schemas.openxmlformats.org/drawingml/2006/main" xmlns:r="http://schemas.openxmlformats.org/officeDocument/2006/relationships" xmlns:p="http://schemas.openxmlformats.org/presentationml/2006/main">
   <p:cSld name="Slide 14">
-    <p:bg>
-      <p:bgPr>
-        <a:blipFill dpi="0" rotWithShape="1">
-          <a:blip r:embed="rId1">
-            <a:lum/>
-          </a:blip>
-          <a:srcRect/>
-          <a:stretch>
-            <a:fillRect/>
-          </a:stretch>
-        </a:blipFill>
-        <a:effectLst/>
-      </p:bgPr>
-    </p:bg>
-    <p:spTree>
-      <p:nvGrpSpPr>
-        <p:cNvPr id="1" name=""/>
-        <p:cNvGrpSpPr/>
-        <p:nvPr/>
-      </p:nvGrpSpPr>
-      <p:grpSpPr>
-        <a:xfrm>
-          <a:off x="0" y="0"/>
-          <a:ext cx="0" cy="0"/>
-          <a:chOff x="0" y="0"/>
-          <a:chExt cx="0" cy="0"/>
-        </a:xfrm>
-      </p:grpSpPr>
-    </p:spTree>
-  </p:cSld>
-  <p:clrMapOvr>
-    <a:masterClrMapping/>
-  </p:clrMapOvr>
-</p:sld>
-</file>
-
-<file path=ppt/slides/slide15.xml><?xml version="1.0" encoding="utf-8"?>
-<p:sld xmlns:a="http://schemas.openxmlformats.org/drawingml/2006/main" xmlns:r="http://schemas.openxmlformats.org/officeDocument/2006/relationships" xmlns:p="http://schemas.openxmlformats.org/presentationml/2006/main">
-  <p:cSld name="Slide 15">
     <p:bg>
       <p:bgPr>
         <a:blipFill dpi="0" rotWithShape="1">

</xml_diff>

<commit_message>
Models deck: add separate Kubeflow and SageMaker architecture diagrams
- kubeflow-architecture.svg: Kubeflow platform (blue) — Dashboard/SDK,
  Pipelines, Spark Operator/Notebooks/Trainer/Katib/KServe*, Hub, Kubernetes
- sagemaker-architecture.svg: SageMaker platform (AWS navy/orange) — Studio/SDK,
  Pipelines, Glue·EMR/Studio Notebooks/Training Jobs/AMT/Endpoints, Registry, EKS·EC2
- slides.md: two new per-platform slides after the combined ≈ capstone
- rebuild slides.pdf + slides.pptx

Co-Authored-By: Claude Opus 4.8 (1M context) <noreply@anthropic.com>
</commit_message>
<xml_diff>
--- a/02-models/slides.pptx
+++ b/02-models/slides.pptx
@@ -19,9 +19,11 @@
     <p:sldId id="267" r:id="rId13"/>
     <p:sldId id="268" r:id="rId14"/>
     <p:sldId id="269" r:id="rId15"/>
+    <p:sldId id="270" r:id="rId16"/>
+    <p:sldId id="271" r:id="rId17"/>
   </p:sldIdLst>
   <p:notesMasterIdLst>
-    <p:notesMasterId r:id="rId16"/>
+    <p:notesMasterId r:id="rId18"/>
   </p:notesMasterIdLst>
   <p:sldSz cx="12192000" cy="6858000"/>
   <p:notesSz cx="6858000" cy="12192000"/>
@@ -967,6 +969,188 @@
           <a:p>
             <a:r>
               <a:rPr lang="en-US" dirty="0"/>
+              <a:t>The open reference. Components are usable standalone or as the full Community
+Distribution. Keep the real names: Spark Operator, Notebooks, Trainer, Katib,
+Hub. KServe is an *ecosystem* project (with Feast, Elyra), not a core component.
+Everything runs on Kubernetes — that's Layer 1.</a:t>
+            </a:r>
+            <a:endParaRPr lang="en-US" dirty="0"/>
+          </a:p>
+        </p:txBody>
+      </p:sp>
+      <p:sp>
+        <p:nvSpPr>
+          <p:cNvPr id="4" name="Slide Number Placeholder 3"/>
+          <p:cNvSpPr>
+            <a:spLocks noGrp="1"/>
+          </p:cNvSpPr>
+          <p:nvPr>
+            <p:ph type="sldNum" sz="quarter" idx="10"/>
+          </p:nvPr>
+        </p:nvSpPr>
+        <p:spPr/>
+        <p:txBody>
+          <a:bodyPr/>
+          <a:lstStyle/>
+          <a:p>
+            <a:fld id="{F7021451-1387-4CA6-816F-3879F97B5CBC}" type="slidenum">
+              <a:rPr lang="en-US"/>
+              <a:t>14</a:t>
+            </a:fld>
+            <a:endParaRPr lang="en-US"/>
+          </a:p>
+        </p:txBody>
+      </p:sp>
+    </p:spTree>
+    <p:extLst>
+      <p:ext uri="{BB962C8B-B14F-4D97-AF65-F5344CB8AC3E}">
+        <p14:creationId xmlns:p14="http://schemas.microsoft.com/office/powerpoint/2010/main" val="1024086991"/>
+      </p:ext>
+    </p:extLst>
+  </p:cSld>
+  <p:clrMapOvr>
+    <a:masterClrMapping/>
+  </p:clrMapOvr>
+</p:notes>
+</file>
+
+<file path=ppt/notesSlides/notesSlide15.xml><?xml version="1.0" encoding="utf-8"?>
+<p:notes xmlns:a="http://schemas.openxmlformats.org/drawingml/2006/main" xmlns:r="http://schemas.openxmlformats.org/officeDocument/2006/relationships" xmlns:p="http://schemas.openxmlformats.org/presentationml/2006/main">
+  <p:cSld>
+    <p:spTree>
+      <p:nvGrpSpPr>
+        <p:cNvPr id="1" name=""/>
+        <p:cNvGrpSpPr/>
+        <p:nvPr/>
+      </p:nvGrpSpPr>
+      <p:grpSpPr>
+        <a:xfrm>
+          <a:off x="0" y="0"/>
+          <a:ext cx="0" cy="0"/>
+          <a:chOff x="0" y="0"/>
+          <a:chExt cx="0" cy="0"/>
+        </a:xfrm>
+      </p:grpSpPr>
+      <p:sp>
+        <p:nvSpPr>
+          <p:cNvPr id="2" name="Slide Image Placeholder 1"/>
+          <p:cNvSpPr>
+            <a:spLocks noGrp="1" noRot="1" noChangeAspect="1"/>
+          </p:cNvSpPr>
+          <p:nvPr>
+            <p:ph type="sldImg"/>
+          </p:nvPr>
+        </p:nvSpPr>
+        <p:spPr/>
+      </p:sp>
+      <p:sp>
+        <p:nvSpPr>
+          <p:cNvPr id="3" name="Notes Placeholder 2"/>
+          <p:cNvSpPr>
+            <a:spLocks noGrp="1"/>
+          </p:cNvSpPr>
+          <p:nvPr>
+            <p:ph type="body" idx="1"/>
+          </p:nvPr>
+        </p:nvSpPr>
+        <p:spPr/>
+        <p:txBody>
+          <a:bodyPr/>
+          <a:lstStyle/>
+          <a:p>
+            <a:r>
+              <a:rPr lang="en-US" dirty="0"/>
+              <a:t>The managed counterpart: the identical lifecycle as AWS services, no cluster to
+run. Training Jobs ≈ Trainer, Automatic Model Tuning ≈ Katib, Endpoints ≈ KServe,
+Model Registry ≈ Hub, SageMaker Pipelines ≈ Kubeflow Pipelines. Lab 2′ runs the
+fine-tune here as a Training Job from a single train.py.</a:t>
+            </a:r>
+            <a:endParaRPr lang="en-US" dirty="0"/>
+          </a:p>
+        </p:txBody>
+      </p:sp>
+      <p:sp>
+        <p:nvSpPr>
+          <p:cNvPr id="4" name="Slide Number Placeholder 3"/>
+          <p:cNvSpPr>
+            <a:spLocks noGrp="1"/>
+          </p:cNvSpPr>
+          <p:nvPr>
+            <p:ph type="sldNum" sz="quarter" idx="10"/>
+          </p:nvPr>
+        </p:nvSpPr>
+        <p:spPr/>
+        <p:txBody>
+          <a:bodyPr/>
+          <a:lstStyle/>
+          <a:p>
+            <a:fld id="{F7021451-1387-4CA6-816F-3879F97B5CBC}" type="slidenum">
+              <a:rPr lang="en-US"/>
+              <a:t>15</a:t>
+            </a:fld>
+            <a:endParaRPr lang="en-US"/>
+          </a:p>
+        </p:txBody>
+      </p:sp>
+    </p:spTree>
+    <p:extLst>
+      <p:ext uri="{BB962C8B-B14F-4D97-AF65-F5344CB8AC3E}">
+        <p14:creationId xmlns:p14="http://schemas.microsoft.com/office/powerpoint/2010/main" val="1024086991"/>
+      </p:ext>
+    </p:extLst>
+  </p:cSld>
+  <p:clrMapOvr>
+    <a:masterClrMapping/>
+  </p:clrMapOvr>
+</p:notes>
+</file>
+
+<file path=ppt/notesSlides/notesSlide16.xml><?xml version="1.0" encoding="utf-8"?>
+<p:notes xmlns:a="http://schemas.openxmlformats.org/drawingml/2006/main" xmlns:r="http://schemas.openxmlformats.org/officeDocument/2006/relationships" xmlns:p="http://schemas.openxmlformats.org/presentationml/2006/main">
+  <p:cSld>
+    <p:spTree>
+      <p:nvGrpSpPr>
+        <p:cNvPr id="1" name=""/>
+        <p:cNvGrpSpPr/>
+        <p:nvPr/>
+      </p:nvGrpSpPr>
+      <p:grpSpPr>
+        <a:xfrm>
+          <a:off x="0" y="0"/>
+          <a:ext cx="0" cy="0"/>
+          <a:chOff x="0" y="0"/>
+          <a:chExt cx="0" cy="0"/>
+        </a:xfrm>
+      </p:grpSpPr>
+      <p:sp>
+        <p:nvSpPr>
+          <p:cNvPr id="2" name="Slide Image Placeholder 1"/>
+          <p:cNvSpPr>
+            <a:spLocks noGrp="1" noRot="1" noChangeAspect="1"/>
+          </p:cNvSpPr>
+          <p:nvPr>
+            <p:ph type="sldImg"/>
+          </p:nvPr>
+        </p:nvSpPr>
+        <p:spPr/>
+      </p:sp>
+      <p:sp>
+        <p:nvSpPr>
+          <p:cNvPr id="3" name="Notes Placeholder 2"/>
+          <p:cNvSpPr>
+            <a:spLocks noGrp="1"/>
+          </p:cNvSpPr>
+          <p:nvPr>
+            <p:ph type="body" idx="1"/>
+          </p:nvPr>
+        </p:nvSpPr>
+        <p:spPr/>
+        <p:txBody>
+          <a:bodyPr/>
+          <a:lstStyle/>
+          <a:p>
+            <a:r>
+              <a:rPr lang="en-US" dirty="0"/>
               <a:t>The part builders use. Students already build oracles and genies. Bostrom's
 ranking (oracle/tool safe, sovereign risky) is a real design choice in layer 4.</a:t>
             </a:r>
@@ -991,7 +1175,7 @@
           <a:p>
             <a:fld id="{F7021451-1387-4CA6-816F-3879F97B5CBC}" type="slidenum">
               <a:rPr lang="en-US"/>
-              <a:t>14</a:t>
+              <a:t>16</a:t>
             </a:fld>
             <a:endParaRPr lang="en-US"/>
           </a:p>
@@ -2229,6 +2413,84 @@
 <file path=ppt/slides/slide14.xml><?xml version="1.0" encoding="utf-8"?>
 <p:sld xmlns:a="http://schemas.openxmlformats.org/drawingml/2006/main" xmlns:r="http://schemas.openxmlformats.org/officeDocument/2006/relationships" xmlns:p="http://schemas.openxmlformats.org/presentationml/2006/main">
   <p:cSld name="Slide 14">
+    <p:bg>
+      <p:bgPr>
+        <a:blipFill dpi="0" rotWithShape="1">
+          <a:blip r:embed="rId1">
+            <a:lum/>
+          </a:blip>
+          <a:srcRect/>
+          <a:stretch>
+            <a:fillRect/>
+          </a:stretch>
+        </a:blipFill>
+        <a:effectLst/>
+      </p:bgPr>
+    </p:bg>
+    <p:spTree>
+      <p:nvGrpSpPr>
+        <p:cNvPr id="1" name=""/>
+        <p:cNvGrpSpPr/>
+        <p:nvPr/>
+      </p:nvGrpSpPr>
+      <p:grpSpPr>
+        <a:xfrm>
+          <a:off x="0" y="0"/>
+          <a:ext cx="0" cy="0"/>
+          <a:chOff x="0" y="0"/>
+          <a:chExt cx="0" cy="0"/>
+        </a:xfrm>
+      </p:grpSpPr>
+    </p:spTree>
+  </p:cSld>
+  <p:clrMapOvr>
+    <a:masterClrMapping/>
+  </p:clrMapOvr>
+</p:sld>
+</file>
+
+<file path=ppt/slides/slide15.xml><?xml version="1.0" encoding="utf-8"?>
+<p:sld xmlns:a="http://schemas.openxmlformats.org/drawingml/2006/main" xmlns:r="http://schemas.openxmlformats.org/officeDocument/2006/relationships" xmlns:p="http://schemas.openxmlformats.org/presentationml/2006/main">
+  <p:cSld name="Slide 15">
+    <p:bg>
+      <p:bgPr>
+        <a:blipFill dpi="0" rotWithShape="1">
+          <a:blip r:embed="rId1">
+            <a:lum/>
+          </a:blip>
+          <a:srcRect/>
+          <a:stretch>
+            <a:fillRect/>
+          </a:stretch>
+        </a:blipFill>
+        <a:effectLst/>
+      </p:bgPr>
+    </p:bg>
+    <p:spTree>
+      <p:nvGrpSpPr>
+        <p:cNvPr id="1" name=""/>
+        <p:cNvGrpSpPr/>
+        <p:nvPr/>
+      </p:nvGrpSpPr>
+      <p:grpSpPr>
+        <a:xfrm>
+          <a:off x="0" y="0"/>
+          <a:ext cx="0" cy="0"/>
+          <a:chOff x="0" y="0"/>
+          <a:chExt cx="0" cy="0"/>
+        </a:xfrm>
+      </p:grpSpPr>
+    </p:spTree>
+  </p:cSld>
+  <p:clrMapOvr>
+    <a:masterClrMapping/>
+  </p:clrMapOvr>
+</p:sld>
+</file>
+
+<file path=ppt/slides/slide16.xml><?xml version="1.0" encoding="utf-8"?>
+<p:sld xmlns:a="http://schemas.openxmlformats.org/drawingml/2006/main" xmlns:r="http://schemas.openxmlformats.org/officeDocument/2006/relationships" xmlns:p="http://schemas.openxmlformats.org/presentationml/2006/main">
+  <p:cSld name="Slide 16">
     <p:bg>
       <p:bgPr>
         <a:blipFill dpi="0" rotWithShape="1">

</xml_diff>

<commit_message>
Models deck: drop combined Kubeflow≈SageMaker slide (duplicated per-platform ones)
- remove the "Systematic view — Kubeflow ≈ SageMaker" slide; the dedicated
  Kubeflow and SageMaker diagram slides below it cover the same ground
- delete now-orphaned systematic-view.svg (no longer referenced)
- rebuild slides.pdf + slides.pptx

Co-Authored-By: Claude Opus 4.8 (1M context) <noreply@anthropic.com>
</commit_message>
<xml_diff>
--- a/02-models/slides.pptx
+++ b/02-models/slides.pptx
@@ -20,10 +20,9 @@
     <p:sldId id="268" r:id="rId14"/>
     <p:sldId id="269" r:id="rId15"/>
     <p:sldId id="270" r:id="rId16"/>
-    <p:sldId id="271" r:id="rId17"/>
   </p:sldIdLst>
   <p:notesMasterIdLst>
-    <p:notesMasterId r:id="rId18"/>
+    <p:notesMasterId r:id="rId17"/>
   </p:notesMasterIdLst>
   <p:sldSz cx="12192000" cy="6858000"/>
   <p:notesSz cx="6858000" cy="12192000"/>
@@ -876,99 +875,6 @@
           <a:p>
             <a:r>
               <a:rPr lang="en-US" dirty="0"/>
-              <a:t>The capstone: our seven phases aren't ad-hoc — they're the lifecycle every
-platform implements. Kubeflow = open, on your Kubernetes; SageMaker = AWS-managed,
-same stages. Keep Kubeflow's real component names. The labs/kubeflow-sagemaker/
-lab re-expresses the Kaggle fine-tune in both: Kubeflow Trainer takes a function,
-SageMaker takes a script, both run the identical train.py. The eval gate (Lab 3)
-becomes a Pipelines step that blocks a regressed deploy.</a:t>
-            </a:r>
-            <a:endParaRPr lang="en-US" dirty="0"/>
-          </a:p>
-        </p:txBody>
-      </p:sp>
-      <p:sp>
-        <p:nvSpPr>
-          <p:cNvPr id="4" name="Slide Number Placeholder 3"/>
-          <p:cNvSpPr>
-            <a:spLocks noGrp="1"/>
-          </p:cNvSpPr>
-          <p:nvPr>
-            <p:ph type="sldNum" sz="quarter" idx="10"/>
-          </p:nvPr>
-        </p:nvSpPr>
-        <p:spPr/>
-        <p:txBody>
-          <a:bodyPr/>
-          <a:lstStyle/>
-          <a:p>
-            <a:fld id="{F7021451-1387-4CA6-816F-3879F97B5CBC}" type="slidenum">
-              <a:rPr lang="en-US"/>
-              <a:t>13</a:t>
-            </a:fld>
-            <a:endParaRPr lang="en-US"/>
-          </a:p>
-        </p:txBody>
-      </p:sp>
-    </p:spTree>
-    <p:extLst>
-      <p:ext uri="{BB962C8B-B14F-4D97-AF65-F5344CB8AC3E}">
-        <p14:creationId xmlns:p14="http://schemas.microsoft.com/office/powerpoint/2010/main" val="1024086991"/>
-      </p:ext>
-    </p:extLst>
-  </p:cSld>
-  <p:clrMapOvr>
-    <a:masterClrMapping/>
-  </p:clrMapOvr>
-</p:notes>
-</file>
-
-<file path=ppt/notesSlides/notesSlide14.xml><?xml version="1.0" encoding="utf-8"?>
-<p:notes xmlns:a="http://schemas.openxmlformats.org/drawingml/2006/main" xmlns:r="http://schemas.openxmlformats.org/officeDocument/2006/relationships" xmlns:p="http://schemas.openxmlformats.org/presentationml/2006/main">
-  <p:cSld>
-    <p:spTree>
-      <p:nvGrpSpPr>
-        <p:cNvPr id="1" name=""/>
-        <p:cNvGrpSpPr/>
-        <p:nvPr/>
-      </p:nvGrpSpPr>
-      <p:grpSpPr>
-        <a:xfrm>
-          <a:off x="0" y="0"/>
-          <a:ext cx="0" cy="0"/>
-          <a:chOff x="0" y="0"/>
-          <a:chExt cx="0" cy="0"/>
-        </a:xfrm>
-      </p:grpSpPr>
-      <p:sp>
-        <p:nvSpPr>
-          <p:cNvPr id="2" name="Slide Image Placeholder 1"/>
-          <p:cNvSpPr>
-            <a:spLocks noGrp="1" noRot="1" noChangeAspect="1"/>
-          </p:cNvSpPr>
-          <p:nvPr>
-            <p:ph type="sldImg"/>
-          </p:nvPr>
-        </p:nvSpPr>
-        <p:spPr/>
-      </p:sp>
-      <p:sp>
-        <p:nvSpPr>
-          <p:cNvPr id="3" name="Notes Placeholder 2"/>
-          <p:cNvSpPr>
-            <a:spLocks noGrp="1"/>
-          </p:cNvSpPr>
-          <p:nvPr>
-            <p:ph type="body" idx="1"/>
-          </p:nvPr>
-        </p:nvSpPr>
-        <p:spPr/>
-        <p:txBody>
-          <a:bodyPr/>
-          <a:lstStyle/>
-          <a:p>
-            <a:r>
-              <a:rPr lang="en-US" dirty="0"/>
               <a:t>The open reference. Components are usable standalone or as the full Community
 Distribution. Keep the real names: Spark Operator, Notebooks, Trainer, Katib,
 Hub. KServe is an *ecosystem* project (with Feast, Elyra), not a core component.
@@ -995,7 +901,7 @@
           <a:p>
             <a:fld id="{F7021451-1387-4CA6-816F-3879F97B5CBC}" type="slidenum">
               <a:rPr lang="en-US"/>
-              <a:t>14</a:t>
+              <a:t>13</a:t>
             </a:fld>
             <a:endParaRPr lang="en-US"/>
           </a:p>
@@ -1014,7 +920,7 @@
 </p:notes>
 </file>
 
-<file path=ppt/notesSlides/notesSlide15.xml><?xml version="1.0" encoding="utf-8"?>
+<file path=ppt/notesSlides/notesSlide14.xml><?xml version="1.0" encoding="utf-8"?>
 <p:notes xmlns:a="http://schemas.openxmlformats.org/drawingml/2006/main" xmlns:r="http://schemas.openxmlformats.org/officeDocument/2006/relationships" xmlns:p="http://schemas.openxmlformats.org/presentationml/2006/main">
   <p:cSld>
     <p:spTree>
@@ -1086,7 +992,7 @@
           <a:p>
             <a:fld id="{F7021451-1387-4CA6-816F-3879F97B5CBC}" type="slidenum">
               <a:rPr lang="en-US"/>
-              <a:t>15</a:t>
+              <a:t>14</a:t>
             </a:fld>
             <a:endParaRPr lang="en-US"/>
           </a:p>
@@ -1105,7 +1011,7 @@
 </p:notes>
 </file>
 
-<file path=ppt/notesSlides/notesSlide16.xml><?xml version="1.0" encoding="utf-8"?>
+<file path=ppt/notesSlides/notesSlide15.xml><?xml version="1.0" encoding="utf-8"?>
 <p:notes xmlns:a="http://schemas.openxmlformats.org/drawingml/2006/main" xmlns:r="http://schemas.openxmlformats.org/officeDocument/2006/relationships" xmlns:p="http://schemas.openxmlformats.org/presentationml/2006/main">
   <p:cSld>
     <p:spTree>
@@ -1175,7 +1081,7 @@
           <a:p>
             <a:fld id="{F7021451-1387-4CA6-816F-3879F97B5CBC}" type="slidenum">
               <a:rPr lang="en-US"/>
-              <a:t>16</a:t>
+              <a:t>15</a:t>
             </a:fld>
             <a:endParaRPr lang="en-US"/>
           </a:p>
@@ -2452,45 +2358,6 @@
 <file path=ppt/slides/slide15.xml><?xml version="1.0" encoding="utf-8"?>
 <p:sld xmlns:a="http://schemas.openxmlformats.org/drawingml/2006/main" xmlns:r="http://schemas.openxmlformats.org/officeDocument/2006/relationships" xmlns:p="http://schemas.openxmlformats.org/presentationml/2006/main">
   <p:cSld name="Slide 15">
-    <p:bg>
-      <p:bgPr>
-        <a:blipFill dpi="0" rotWithShape="1">
-          <a:blip r:embed="rId1">
-            <a:lum/>
-          </a:blip>
-          <a:srcRect/>
-          <a:stretch>
-            <a:fillRect/>
-          </a:stretch>
-        </a:blipFill>
-        <a:effectLst/>
-      </p:bgPr>
-    </p:bg>
-    <p:spTree>
-      <p:nvGrpSpPr>
-        <p:cNvPr id="1" name=""/>
-        <p:cNvGrpSpPr/>
-        <p:nvPr/>
-      </p:nvGrpSpPr>
-      <p:grpSpPr>
-        <a:xfrm>
-          <a:off x="0" y="0"/>
-          <a:ext cx="0" cy="0"/>
-          <a:chOff x="0" y="0"/>
-          <a:chExt cx="0" cy="0"/>
-        </a:xfrm>
-      </p:grpSpPr>
-    </p:spTree>
-  </p:cSld>
-  <p:clrMapOvr>
-    <a:masterClrMapping/>
-  </p:clrMapOvr>
-</p:sld>
-</file>
-
-<file path=ppt/slides/slide16.xml><?xml version="1.0" encoding="utf-8"?>
-<p:sld xmlns:a="http://schemas.openxmlformats.org/drawingml/2006/main" xmlns:r="http://schemas.openxmlformats.org/officeDocument/2006/relationships" xmlns:p="http://schemas.openxmlformats.org/presentationml/2006/main">
-  <p:cSld name="Slide 16">
     <p:bg>
       <p:bgPr>
         <a:blipFill dpi="0" rotWithShape="1">

</xml_diff>